<commit_message>
Añadir PBIX con datos guardados y actualizar la documentación final
</commit_message>
<xml_diff>
--- a/docs/TFM_Favorita_presentacion_final.pptx
+++ b/docs/TFM_Favorita_presentacion_final.pptx
@@ -2,18 +2,18 @@
 <file path=ppt/presentation.xml><?xml version="1.0" encoding="utf-8"?>
 <p:presentation xmlns:p="http://schemas.openxmlformats.org/presentationml/2006/main">
   <p:sldMasterIdLst>
-    <p:sldMasterId xmlns:r="http://schemas.openxmlformats.org/officeDocument/2006/relationships" id="2147483648" r:id="R1d549dee09c64f55"/>
+    <p:sldMasterId xmlns:r="http://schemas.openxmlformats.org/officeDocument/2006/relationships" id="2147483648" r:id="Rea28a01092054db9"/>
   </p:sldMasterIdLst>
   <p:notesMasterIdLst>
-    <p:notesMasterId xmlns:r="http://schemas.openxmlformats.org/officeDocument/2006/relationships" r:id="Rdd2ebe12dcb841f9"/>
+    <p:notesMasterId xmlns:r="http://schemas.openxmlformats.org/officeDocument/2006/relationships" r:id="R10f459d666a545fc"/>
   </p:notesMasterIdLst>
   <p:sldIdLst>
-    <p:sldId xmlns:r="http://schemas.openxmlformats.org/officeDocument/2006/relationships" id="256" r:id="Rba61f29ff4574172"/>
-    <p:sldId xmlns:r="http://schemas.openxmlformats.org/officeDocument/2006/relationships" id="257" r:id="R2f03e7bab5934414"/>
-    <p:sldId xmlns:r="http://schemas.openxmlformats.org/officeDocument/2006/relationships" id="258" r:id="Rc407dd2035b64af3"/>
-    <p:sldId xmlns:r="http://schemas.openxmlformats.org/officeDocument/2006/relationships" id="259" r:id="R4bbdefa1bb1a4b20"/>
-    <p:sldId xmlns:r="http://schemas.openxmlformats.org/officeDocument/2006/relationships" id="260" r:id="Rd0984fe49fc34a26"/>
-    <p:sldId xmlns:r="http://schemas.openxmlformats.org/officeDocument/2006/relationships" id="261" r:id="R2b8d633b293545ff"/>
+    <p:sldId xmlns:r="http://schemas.openxmlformats.org/officeDocument/2006/relationships" id="256" r:id="R46367fdc41374b62"/>
+    <p:sldId xmlns:r="http://schemas.openxmlformats.org/officeDocument/2006/relationships" id="257" r:id="R9ff0cdf530ab4114"/>
+    <p:sldId xmlns:r="http://schemas.openxmlformats.org/officeDocument/2006/relationships" id="258" r:id="Rc1c0abb7f7d947ba"/>
+    <p:sldId xmlns:r="http://schemas.openxmlformats.org/officeDocument/2006/relationships" id="259" r:id="Rf3f10b09229048d1"/>
+    <p:sldId xmlns:r="http://schemas.openxmlformats.org/officeDocument/2006/relationships" id="260" r:id="Rb2f1d609c2f4436b"/>
+    <p:sldId xmlns:r="http://schemas.openxmlformats.org/officeDocument/2006/relationships" id="261" r:id="R20287cfa12d54a73"/>
   </p:sldIdLst>
   <p:sldSz cx="12192000" cy="6858000"/>
   <p:notesSz cx="6858000" cy="9144000"/>
@@ -797,7 +797,7 @@
           <a:lstStyle xmlns:a="http://schemas.openxmlformats.org/drawingml/2006/main"/>
           <a:p xmlns:a="http://schemas.openxmlformats.org/drawingml/2006/main">
             <a:r>
-              <a:t>El resultado final incluye 28.512 previsiones para los 16 días siguientes y un proyecto nativo de Power BI con dos páginas. La primera permite filtrar por tienda, familia y modelo y exportar las previsiones. La segunda muestra los errores del test interno. He comprobado la estructura del informe y que sus CSV reproducen las métricas. Queda verificar la apertura y el refresco en Power BI Desktop. Como siguiente paso ampliaría el backtesting a otros periodos y validaría el dashboard con un usuario. Con datos de inventario también podría estudiar roturas de stock, pero con este dataset el alcance sigue siendo ventas. Fuentes: powerbi/Favorita.pbip y outputs/powerbi_validation.json.</a:t>
+              <a:t>El resultado final incluye 28.512 previsiones para los 16 días siguientes y un proyecto nativo de Power BI con dos páginas. La primera permite filtrar por tienda, familia y modelo y exportar las previsiones. La segunda muestra los errores del test interno. He comprobado la estructura del informe y que sus CSV reproducen las métricas. El proyecto se ha abierto en Power BI Desktop y se entrega también como PBIX con datos. Queda confirmar el refresco explícito y la interacción completa. Como siguiente paso ampliaría el backtesting a otros periodos y validaría el dashboard con un usuario. Con datos de inventario también podría estudiar roturas de stock, pero con este dataset el alcance sigue siendo ventas. Fuentes: powerbi/Favorita.pbip y outputs/powerbi_validation.json.</a:t>
             </a:r>
           </a:p>
         </p:txBody>
@@ -844,7 +844,7 @@
           <p:cNvPr id="4" name="Accent rule">
             <a:extLst xmlns:a="http://schemas.openxmlformats.org/drawingml/2006/main">
               <a:ext uri="{FF2B5EF4-FFF2-40B4-BE49-F238E27FC236}">
-                <a16:creationId xmlns:a16="http://schemas.microsoft.com/office/drawing/2014/main" id="{1CE9E879-0DC4-4B67-8480-7D4A49A2A2E0}"/>
+                <a16:creationId xmlns:a16="http://schemas.microsoft.com/office/drawing/2014/main" id="{AA8E893C-3631-457E-979B-A64AE60FC95D}"/>
               </a:ext>
             </a:extLst>
           </p:cNvPr>
@@ -875,7 +875,7 @@
           <p:cNvPr id="2" name="Title">
             <a:extLst xmlns:a="http://schemas.openxmlformats.org/drawingml/2006/main">
               <a:ext uri="{FF2B5EF4-FFF2-40B4-BE49-F238E27FC236}">
-                <a16:creationId xmlns:a16="http://schemas.microsoft.com/office/drawing/2014/main" id="{8052A93A-77B2-41B6-B514-1E780127B5E8}"/>
+                <a16:creationId xmlns:a16="http://schemas.microsoft.com/office/drawing/2014/main" id="{F166CE0C-DF72-49CA-B1D1-70C077E22150}"/>
               </a:ext>
             </a:extLst>
           </p:cNvPr>
@@ -1022,7 +1022,7 @@
           <p:cNvPr id="3" name="Subtitle">
             <a:extLst xmlns:a="http://schemas.openxmlformats.org/drawingml/2006/main">
               <a:ext uri="{FF2B5EF4-FFF2-40B4-BE49-F238E27FC236}">
-                <a16:creationId xmlns:a16="http://schemas.microsoft.com/office/drawing/2014/main" id="{4CBF2AA4-830B-4B15-A0F7-EB5736B25467}"/>
+                <a16:creationId xmlns:a16="http://schemas.microsoft.com/office/drawing/2014/main" id="{FBDE6C2C-71B1-4184-98FA-282755632744}"/>
               </a:ext>
             </a:extLst>
           </p:cNvPr>
@@ -1186,7 +1186,7 @@
           <p:cNvPr id="3" name="Accent rule">
             <a:extLst xmlns:a="http://schemas.openxmlformats.org/drawingml/2006/main">
               <a:ext uri="{FF2B5EF4-FFF2-40B4-BE49-F238E27FC236}">
-                <a16:creationId xmlns:a16="http://schemas.microsoft.com/office/drawing/2014/main" id="{26B42CBA-0385-4682-8F23-D3012FAE3CBE}"/>
+                <a16:creationId xmlns:a16="http://schemas.microsoft.com/office/drawing/2014/main" id="{7ABE07E1-9DF8-4EE9-9D66-4C79EF6569BD}"/>
               </a:ext>
             </a:extLst>
           </p:cNvPr>
@@ -1217,7 +1217,7 @@
           <p:cNvPr id="2" name="Section title">
             <a:extLst xmlns:a="http://schemas.openxmlformats.org/drawingml/2006/main">
               <a:ext uri="{FF2B5EF4-FFF2-40B4-BE49-F238E27FC236}">
-                <a16:creationId xmlns:a16="http://schemas.microsoft.com/office/drawing/2014/main" id="{CB23C90F-7CDF-45D1-B3E4-C2FB952A24C9}"/>
+                <a16:creationId xmlns:a16="http://schemas.microsoft.com/office/drawing/2014/main" id="{F138F6FE-65AA-4781-A681-599FD89A51C3}"/>
               </a:ext>
             </a:extLst>
           </p:cNvPr>
@@ -1381,7 +1381,7 @@
           <p:cNvPr id="4" name="Accent rule">
             <a:extLst xmlns:a="http://schemas.openxmlformats.org/drawingml/2006/main">
               <a:ext uri="{FF2B5EF4-FFF2-40B4-BE49-F238E27FC236}">
-                <a16:creationId xmlns:a16="http://schemas.microsoft.com/office/drawing/2014/main" id="{23EF21FA-EB93-486B-B9F6-BC10280257D7}"/>
+                <a16:creationId xmlns:a16="http://schemas.microsoft.com/office/drawing/2014/main" id="{3041289E-F9A1-49CD-96F2-915E79DCBFA4}"/>
               </a:ext>
             </a:extLst>
           </p:cNvPr>
@@ -1412,7 +1412,7 @@
           <p:cNvPr id="2" name="Title">
             <a:extLst xmlns:a="http://schemas.openxmlformats.org/drawingml/2006/main">
               <a:ext uri="{FF2B5EF4-FFF2-40B4-BE49-F238E27FC236}">
-                <a16:creationId xmlns:a16="http://schemas.microsoft.com/office/drawing/2014/main" id="{8DC7D2E4-5C82-4FB7-8E93-CA2F0B190E7B}"/>
+                <a16:creationId xmlns:a16="http://schemas.microsoft.com/office/drawing/2014/main" id="{650DD3FC-FE28-4320-BD1C-ED43D4B20326}"/>
               </a:ext>
             </a:extLst>
           </p:cNvPr>
@@ -1559,7 +1559,7 @@
           <p:cNvPr id="3" name="Body">
             <a:extLst xmlns:a="http://schemas.openxmlformats.org/drawingml/2006/main">
               <a:ext uri="{FF2B5EF4-FFF2-40B4-BE49-F238E27FC236}">
-                <a16:creationId xmlns:a16="http://schemas.microsoft.com/office/drawing/2014/main" id="{4331578C-9AE2-44B5-BFB1-846701F2803E}"/>
+                <a16:creationId xmlns:a16="http://schemas.microsoft.com/office/drawing/2014/main" id="{D50CB02F-6E86-44DE-BA8C-14883AE18799}"/>
               </a:ext>
             </a:extLst>
           </p:cNvPr>
@@ -1723,7 +1723,7 @@
           <p:cNvPr id="5" name="Accent rule">
             <a:extLst xmlns:a="http://schemas.openxmlformats.org/drawingml/2006/main">
               <a:ext uri="{FF2B5EF4-FFF2-40B4-BE49-F238E27FC236}">
-                <a16:creationId xmlns:a16="http://schemas.microsoft.com/office/drawing/2014/main" id="{5CA05A22-050C-441F-ADF0-19ABD037D7DD}"/>
+                <a16:creationId xmlns:a16="http://schemas.microsoft.com/office/drawing/2014/main" id="{0CC09D06-21F1-42ED-A0DD-3B3AD0170057}"/>
               </a:ext>
             </a:extLst>
           </p:cNvPr>
@@ -1754,7 +1754,7 @@
           <p:cNvPr id="2" name="Title">
             <a:extLst xmlns:a="http://schemas.openxmlformats.org/drawingml/2006/main">
               <a:ext uri="{FF2B5EF4-FFF2-40B4-BE49-F238E27FC236}">
-                <a16:creationId xmlns:a16="http://schemas.microsoft.com/office/drawing/2014/main" id="{93B73B8E-F826-4945-9600-59CE1A7BA343}"/>
+                <a16:creationId xmlns:a16="http://schemas.microsoft.com/office/drawing/2014/main" id="{D7B54239-0104-4888-8ECB-A328497DE58D}"/>
               </a:ext>
             </a:extLst>
           </p:cNvPr>
@@ -1901,7 +1901,7 @@
           <p:cNvPr id="3" name="Left column">
             <a:extLst xmlns:a="http://schemas.openxmlformats.org/drawingml/2006/main">
               <a:ext uri="{FF2B5EF4-FFF2-40B4-BE49-F238E27FC236}">
-                <a16:creationId xmlns:a16="http://schemas.microsoft.com/office/drawing/2014/main" id="{3E0D76B6-7563-4B48-9547-9461C0BD9177}"/>
+                <a16:creationId xmlns:a16="http://schemas.microsoft.com/office/drawing/2014/main" id="{56DF7E75-6544-4378-93BF-0B1FD02235A2}"/>
               </a:ext>
             </a:extLst>
           </p:cNvPr>
@@ -2048,7 +2048,7 @@
           <p:cNvPr id="4" name="Right column">
             <a:extLst xmlns:a="http://schemas.openxmlformats.org/drawingml/2006/main">
               <a:ext uri="{FF2B5EF4-FFF2-40B4-BE49-F238E27FC236}">
-                <a16:creationId xmlns:a16="http://schemas.microsoft.com/office/drawing/2014/main" id="{EE42CEE2-0103-4D49-BCB7-02201A05945D}"/>
+                <a16:creationId xmlns:a16="http://schemas.microsoft.com/office/drawing/2014/main" id="{D8C6BB74-606E-498E-9A22-AD228B454845}"/>
               </a:ext>
             </a:extLst>
           </p:cNvPr>
@@ -2212,7 +2212,7 @@
           <p:cNvPr id="4" name="Accent rule">
             <a:extLst xmlns:a="http://schemas.openxmlformats.org/drawingml/2006/main">
               <a:ext uri="{FF2B5EF4-FFF2-40B4-BE49-F238E27FC236}">
-                <a16:creationId xmlns:a16="http://schemas.microsoft.com/office/drawing/2014/main" id="{6F34C7E4-2AC8-4802-99FC-FCCE696186E7}"/>
+                <a16:creationId xmlns:a16="http://schemas.microsoft.com/office/drawing/2014/main" id="{4B0D231F-90F7-41A1-84C0-5BB65ADAB1D4}"/>
               </a:ext>
             </a:extLst>
           </p:cNvPr>
@@ -2243,7 +2243,7 @@
           <p:cNvPr id="2" name="Title">
             <a:extLst xmlns:a="http://schemas.openxmlformats.org/drawingml/2006/main">
               <a:ext uri="{FF2B5EF4-FFF2-40B4-BE49-F238E27FC236}">
-                <a16:creationId xmlns:a16="http://schemas.microsoft.com/office/drawing/2014/main" id="{88A11AE7-F590-47DE-BF52-3BA5BCFE24AA}"/>
+                <a16:creationId xmlns:a16="http://schemas.microsoft.com/office/drawing/2014/main" id="{12923B7D-F2D7-4FB3-915E-40B673B5D022}"/>
               </a:ext>
             </a:extLst>
           </p:cNvPr>
@@ -2390,7 +2390,7 @@
           <p:cNvPr id="3" name="Left column">
             <a:extLst xmlns:a="http://schemas.openxmlformats.org/drawingml/2006/main">
               <a:ext uri="{FF2B5EF4-FFF2-40B4-BE49-F238E27FC236}">
-                <a16:creationId xmlns:a16="http://schemas.microsoft.com/office/drawing/2014/main" id="{8F78DD10-621F-45F3-99D4-3B7EB781CC11}"/>
+                <a16:creationId xmlns:a16="http://schemas.microsoft.com/office/drawing/2014/main" id="{D822C72C-5E9B-493C-82AE-805942059856}"/>
               </a:ext>
             </a:extLst>
           </p:cNvPr>
@@ -2575,12 +2575,12 @@
   </p:cSld>
   <p:clrMap bg1="lt1" tx1="dk1" bg2="lt2" tx2="dk2" accent1="accent1" accent2="accent2" accent3="accent3" accent4="accent4" accent5="accent5" accent6="accent6" hlink="hlink" folHlink="folHlink"/>
   <p:sldLayoutIdLst>
-    <p:sldLayoutId xmlns:r="http://schemas.openxmlformats.org/officeDocument/2006/relationships" id="2147483649" r:id="Reac71603734840ae"/>
-    <p:sldLayoutId xmlns:r="http://schemas.openxmlformats.org/officeDocument/2006/relationships" id="2147483650" r:id="R7be4347a80ed4e52"/>
-    <p:sldLayoutId xmlns:r="http://schemas.openxmlformats.org/officeDocument/2006/relationships" id="2147483651" r:id="R011965d100b94d82"/>
-    <p:sldLayoutId xmlns:r="http://schemas.openxmlformats.org/officeDocument/2006/relationships" id="2147483652" r:id="Rb019ffef63034cb1"/>
-    <p:sldLayoutId xmlns:r="http://schemas.openxmlformats.org/officeDocument/2006/relationships" id="2147483653" r:id="R2cedb1f7bd4b4e63"/>
-    <p:sldLayoutId xmlns:r="http://schemas.openxmlformats.org/officeDocument/2006/relationships" id="2147483654" r:id="R7f9eff77df6b4e8d"/>
+    <p:sldLayoutId xmlns:r="http://schemas.openxmlformats.org/officeDocument/2006/relationships" id="2147483649" r:id="R2a8e22c4ff5d4844"/>
+    <p:sldLayoutId xmlns:r="http://schemas.openxmlformats.org/officeDocument/2006/relationships" id="2147483650" r:id="Ra6051cd8bfac412e"/>
+    <p:sldLayoutId xmlns:r="http://schemas.openxmlformats.org/officeDocument/2006/relationships" id="2147483651" r:id="Ra1bb85257ab14c7f"/>
+    <p:sldLayoutId xmlns:r="http://schemas.openxmlformats.org/officeDocument/2006/relationships" id="2147483652" r:id="Rd1d72a06f241463c"/>
+    <p:sldLayoutId xmlns:r="http://schemas.openxmlformats.org/officeDocument/2006/relationships" id="2147483653" r:id="Rd1f46cf7cfeb4b87"/>
+    <p:sldLayoutId xmlns:r="http://schemas.openxmlformats.org/officeDocument/2006/relationships" id="2147483654" r:id="Ra274fae5cab743b6"/>
   </p:sldLayoutIdLst>
   <p:txStyles>
     <p:titleStyle>
@@ -3571,7 +3571,7 @@
           <p:cNvPr id="5" name="">
             <a:extLst xmlns:a="http://schemas.openxmlformats.org/drawingml/2006/main">
               <a:ext uri="{FF2B5EF4-FFF2-40B4-BE49-F238E27FC236}">
-                <a16:creationId xmlns:a16="http://schemas.microsoft.com/office/drawing/2014/main" id="{5F7DE71B-3937-48A4-8988-F3999A6C4CCF}"/>
+                <a16:creationId xmlns:a16="http://schemas.microsoft.com/office/drawing/2014/main" id="{9DF6B8C9-C5CE-4B35-9A58-A1109DC7D7E0}"/>
               </a:ext>
             </a:extLst>
           </p:cNvPr>
@@ -3651,7 +3651,7 @@
           <p:cNvPr id="2" name="">
             <a:extLst xmlns:a="http://schemas.openxmlformats.org/drawingml/2006/main">
               <a:ext uri="{FF2B5EF4-FFF2-40B4-BE49-F238E27FC236}">
-                <a16:creationId xmlns:a16="http://schemas.microsoft.com/office/drawing/2014/main" id="{37699EF8-0969-42DF-BB3F-273FDC7AE11B}"/>
+                <a16:creationId xmlns:a16="http://schemas.microsoft.com/office/drawing/2014/main" id="{A22BC527-EF20-4054-9099-0B444101B3FF}"/>
               </a:ext>
             </a:extLst>
           </p:cNvPr>
@@ -3708,7 +3708,7 @@
           <p:cNvPr id="3" name="">
             <a:extLst xmlns:a="http://schemas.openxmlformats.org/drawingml/2006/main">
               <a:ext uri="{FF2B5EF4-FFF2-40B4-BE49-F238E27FC236}">
-                <a16:creationId xmlns:a16="http://schemas.microsoft.com/office/drawing/2014/main" id="{978647BD-28F3-4643-947E-885B797C3DAF}"/>
+                <a16:creationId xmlns:a16="http://schemas.microsoft.com/office/drawing/2014/main" id="{D19E9AA0-1E72-4D8B-B31D-B69F04AC570B}"/>
               </a:ext>
             </a:extLst>
           </p:cNvPr>
@@ -3788,7 +3788,7 @@
           <p:cNvPr id="4" name="">
             <a:extLst xmlns:a="http://schemas.openxmlformats.org/drawingml/2006/main">
               <a:ext uri="{FF2B5EF4-FFF2-40B4-BE49-F238E27FC236}">
-                <a16:creationId xmlns:a16="http://schemas.microsoft.com/office/drawing/2014/main" id="{A68CD11F-A1B1-4328-BE1E-ED2C90DD73BA}"/>
+                <a16:creationId xmlns:a16="http://schemas.microsoft.com/office/drawing/2014/main" id="{8FE58AF9-2539-40D9-83C1-30EC9DC5703C}"/>
               </a:ext>
             </a:extLst>
           </p:cNvPr>
@@ -3843,7 +3843,7 @@
     </p:spTree>
     <p:extLst>
       <p:ext uri="{BB962C8B-B14F-4D97-AF65-F5344CB8AC3E}">
-        <p14:creationId xmlns:p14="http://schemas.microsoft.com/office/powerpoint/2010/main" val="1242464793"/>
+        <p14:creationId xmlns:p14="http://schemas.microsoft.com/office/powerpoint/2010/main" val="1745842953"/>
       </p:ext>
     </p:extLst>
   </p:cSld>
@@ -3874,7 +3874,7 @@
           <p:cNvPr id="9" name="">
             <a:extLst xmlns:a="http://schemas.openxmlformats.org/drawingml/2006/main">
               <a:ext uri="{FF2B5EF4-FFF2-40B4-BE49-F238E27FC236}">
-                <a16:creationId xmlns:a16="http://schemas.microsoft.com/office/drawing/2014/main" id="{130B490D-91ED-47DD-84C6-ACBA9F912A30}"/>
+                <a16:creationId xmlns:a16="http://schemas.microsoft.com/office/drawing/2014/main" id="{DEB56054-0059-49C6-83A4-B78D2AAD2A70}"/>
               </a:ext>
             </a:extLst>
           </p:cNvPr>
@@ -3931,7 +3931,7 @@
           <p:cNvPr id="2" name="">
             <a:extLst xmlns:a="http://schemas.openxmlformats.org/drawingml/2006/main">
               <a:ext uri="{FF2B5EF4-FFF2-40B4-BE49-F238E27FC236}">
-                <a16:creationId xmlns:a16="http://schemas.microsoft.com/office/drawing/2014/main" id="{AE7CAF13-3CBB-45C9-9F41-60C849C244FE}"/>
+                <a16:creationId xmlns:a16="http://schemas.microsoft.com/office/drawing/2014/main" id="{865B54E5-059C-4106-8E82-EFA8B7E09C0E}"/>
               </a:ext>
             </a:extLst>
           </p:cNvPr>
@@ -3988,7 +3988,7 @@
           <p:cNvPr id="3" name="">
             <a:extLst xmlns:a="http://schemas.openxmlformats.org/drawingml/2006/main">
               <a:ext uri="{FF2B5EF4-FFF2-40B4-BE49-F238E27FC236}">
-                <a16:creationId xmlns:a16="http://schemas.microsoft.com/office/drawing/2014/main" id="{A5B2C3C5-3934-4C17-96D5-1480CDFDB7BC}"/>
+                <a16:creationId xmlns:a16="http://schemas.microsoft.com/office/drawing/2014/main" id="{446C99B1-0C28-40E2-8277-3724FCC80280}"/>
               </a:ext>
             </a:extLst>
           </p:cNvPr>
@@ -4045,7 +4045,7 @@
           <p:cNvPr id="4" name="">
             <a:extLst xmlns:a="http://schemas.openxmlformats.org/drawingml/2006/main">
               <a:ext uri="{FF2B5EF4-FFF2-40B4-BE49-F238E27FC236}">
-                <a16:creationId xmlns:a16="http://schemas.microsoft.com/office/drawing/2014/main" id="{135E95AF-302D-4707-B638-610D30B2E8C3}"/>
+                <a16:creationId xmlns:a16="http://schemas.microsoft.com/office/drawing/2014/main" id="{A06D0C0A-E98B-480C-B58A-7A23B81E0923}"/>
               </a:ext>
             </a:extLst>
           </p:cNvPr>
@@ -4148,7 +4148,7 @@
           <p:cNvPr id="5" name="">
             <a:extLst xmlns:a="http://schemas.openxmlformats.org/drawingml/2006/main">
               <a:ext uri="{FF2B5EF4-FFF2-40B4-BE49-F238E27FC236}">
-                <a16:creationId xmlns:a16="http://schemas.microsoft.com/office/drawing/2014/main" id="{8E6B4220-64CE-44D3-9E00-AC57F028252B}"/>
+                <a16:creationId xmlns:a16="http://schemas.microsoft.com/office/drawing/2014/main" id="{26E25047-81B4-42C2-81F9-4186AF9F3B56}"/>
               </a:ext>
             </a:extLst>
           </p:cNvPr>
@@ -4251,7 +4251,7 @@
           <p:cNvPr id="6" name="">
             <a:extLst xmlns:a="http://schemas.openxmlformats.org/drawingml/2006/main">
               <a:ext uri="{FF2B5EF4-FFF2-40B4-BE49-F238E27FC236}">
-                <a16:creationId xmlns:a16="http://schemas.microsoft.com/office/drawing/2014/main" id="{97BE3191-31DA-4F67-B549-BC8B9F468D02}"/>
+                <a16:creationId xmlns:a16="http://schemas.microsoft.com/office/drawing/2014/main" id="{C439F88A-0854-4408-86AB-3F4AAC0B57EE}"/>
               </a:ext>
             </a:extLst>
           </p:cNvPr>
@@ -4338,7 +4338,7 @@
         </p:xfrm>
         <a:graphic xmlns:a="http://schemas.openxmlformats.org/drawingml/2006/main">
           <a:graphicData uri="http://schemas.openxmlformats.org/drawingml/2006/chart">
-            <c:chart xmlns:r="http://schemas.openxmlformats.org/officeDocument/2006/relationships" xmlns:c="http://schemas.openxmlformats.org/drawingml/2006/chart" r:id="R51cd3f55fb34458f"/>
+            <c:chart xmlns:r="http://schemas.openxmlformats.org/officeDocument/2006/relationships" xmlns:c="http://schemas.openxmlformats.org/drawingml/2006/chart" r:id="Rd0f0062e579d41e8"/>
           </a:graphicData>
         </a:graphic>
       </p:graphicFrame>
@@ -4347,7 +4347,7 @@
           <p:cNvPr id="8" name="">
             <a:extLst xmlns:a="http://schemas.openxmlformats.org/drawingml/2006/main">
               <a:ext uri="{FF2B5EF4-FFF2-40B4-BE49-F238E27FC236}">
-                <a16:creationId xmlns:a16="http://schemas.microsoft.com/office/drawing/2014/main" id="{C290B11E-233C-4136-BDA1-49555417BDBB}"/>
+                <a16:creationId xmlns:a16="http://schemas.microsoft.com/office/drawing/2014/main" id="{98E822BF-3767-4253-9DCE-00086D9A7871}"/>
               </a:ext>
             </a:extLst>
           </p:cNvPr>
@@ -4402,7 +4402,7 @@
     </p:spTree>
     <p:extLst>
       <p:ext uri="{BB962C8B-B14F-4D97-AF65-F5344CB8AC3E}">
-        <p14:creationId xmlns:p14="http://schemas.microsoft.com/office/powerpoint/2010/main" val="566824830"/>
+        <p14:creationId xmlns:p14="http://schemas.microsoft.com/office/powerpoint/2010/main" val="82237467"/>
       </p:ext>
     </p:extLst>
   </p:cSld>
@@ -4433,7 +4433,7 @@
           <p:cNvPr id="7" name="">
             <a:extLst xmlns:a="http://schemas.openxmlformats.org/drawingml/2006/main">
               <a:ext uri="{FF2B5EF4-FFF2-40B4-BE49-F238E27FC236}">
-                <a16:creationId xmlns:a16="http://schemas.microsoft.com/office/drawing/2014/main" id="{9BE4BF4A-DFDA-4C1A-9C42-D8E746CFB0C4}"/>
+                <a16:creationId xmlns:a16="http://schemas.microsoft.com/office/drawing/2014/main" id="{E04D5070-9964-4AC0-81C6-3F91BFBD4453}"/>
               </a:ext>
             </a:extLst>
           </p:cNvPr>
@@ -4490,7 +4490,7 @@
           <p:cNvPr id="2" name="">
             <a:extLst xmlns:a="http://schemas.openxmlformats.org/drawingml/2006/main">
               <a:ext uri="{FF2B5EF4-FFF2-40B4-BE49-F238E27FC236}">
-                <a16:creationId xmlns:a16="http://schemas.microsoft.com/office/drawing/2014/main" id="{7D303ABB-6E1B-4BA6-81F3-66ED38B43EE2}"/>
+                <a16:creationId xmlns:a16="http://schemas.microsoft.com/office/drawing/2014/main" id="{B4C3239A-7805-4FCF-A4A5-06D977133362}"/>
               </a:ext>
             </a:extLst>
           </p:cNvPr>
@@ -4547,7 +4547,7 @@
           <p:cNvPr id="3" name="">
             <a:extLst xmlns:a="http://schemas.openxmlformats.org/drawingml/2006/main">
               <a:ext uri="{FF2B5EF4-FFF2-40B4-BE49-F238E27FC236}">
-                <a16:creationId xmlns:a16="http://schemas.microsoft.com/office/drawing/2014/main" id="{F184891D-B0CC-4A5B-B382-E9CF448696C6}"/>
+                <a16:creationId xmlns:a16="http://schemas.microsoft.com/office/drawing/2014/main" id="{443ADFA1-1AAA-47DA-B2A8-3AB10BEEF029}"/>
               </a:ext>
             </a:extLst>
           </p:cNvPr>
@@ -4962,7 +4962,7 @@
           <p:cNvPr id="5" name="">
             <a:extLst xmlns:a="http://schemas.openxmlformats.org/drawingml/2006/main">
               <a:ext uri="{FF2B5EF4-FFF2-40B4-BE49-F238E27FC236}">
-                <a16:creationId xmlns:a16="http://schemas.microsoft.com/office/drawing/2014/main" id="{C4D01943-BF31-452B-B7F6-FC4469751AEB}"/>
+                <a16:creationId xmlns:a16="http://schemas.microsoft.com/office/drawing/2014/main" id="{10F91862-187B-46FC-B9E7-2BCE5292FD51}"/>
               </a:ext>
             </a:extLst>
           </p:cNvPr>
@@ -5019,7 +5019,7 @@
           <p:cNvPr id="6" name="">
             <a:extLst xmlns:a="http://schemas.openxmlformats.org/drawingml/2006/main">
               <a:ext uri="{FF2B5EF4-FFF2-40B4-BE49-F238E27FC236}">
-                <a16:creationId xmlns:a16="http://schemas.microsoft.com/office/drawing/2014/main" id="{C2AE1A7E-7812-4DA7-90B7-B0F670AC3947}"/>
+                <a16:creationId xmlns:a16="http://schemas.microsoft.com/office/drawing/2014/main" id="{83ADC6B4-3675-40FF-AE6A-52FE86B9A646}"/>
               </a:ext>
             </a:extLst>
           </p:cNvPr>
@@ -5074,7 +5074,7 @@
     </p:spTree>
     <p:extLst>
       <p:ext uri="{BB962C8B-B14F-4D97-AF65-F5344CB8AC3E}">
-        <p14:creationId xmlns:p14="http://schemas.microsoft.com/office/powerpoint/2010/main" val="1516364642"/>
+        <p14:creationId xmlns:p14="http://schemas.microsoft.com/office/powerpoint/2010/main" val="541911449"/>
       </p:ext>
     </p:extLst>
   </p:cSld>
@@ -5105,7 +5105,7 @@
           <p:cNvPr id="7" name="">
             <a:extLst xmlns:a="http://schemas.openxmlformats.org/drawingml/2006/main">
               <a:ext uri="{FF2B5EF4-FFF2-40B4-BE49-F238E27FC236}">
-                <a16:creationId xmlns:a16="http://schemas.microsoft.com/office/drawing/2014/main" id="{05F7442B-8E70-45B9-833F-7E8BC80F69B6}"/>
+                <a16:creationId xmlns:a16="http://schemas.microsoft.com/office/drawing/2014/main" id="{5F4C5C8E-71DD-4A58-AB36-CBC24598DD36}"/>
               </a:ext>
             </a:extLst>
           </p:cNvPr>
@@ -5162,7 +5162,7 @@
           <p:cNvPr id="2" name="">
             <a:extLst xmlns:a="http://schemas.openxmlformats.org/drawingml/2006/main">
               <a:ext uri="{FF2B5EF4-FFF2-40B4-BE49-F238E27FC236}">
-                <a16:creationId xmlns:a16="http://schemas.microsoft.com/office/drawing/2014/main" id="{1E46FC99-B016-4414-9DBB-BD289751817F}"/>
+                <a16:creationId xmlns:a16="http://schemas.microsoft.com/office/drawing/2014/main" id="{28EA6E80-145F-40B8-ADD6-B40C9219114C}"/>
               </a:ext>
             </a:extLst>
           </p:cNvPr>
@@ -5219,7 +5219,7 @@
           <p:cNvPr id="3" name="">
             <a:extLst xmlns:a="http://schemas.openxmlformats.org/drawingml/2006/main">
               <a:ext uri="{FF2B5EF4-FFF2-40B4-BE49-F238E27FC236}">
-                <a16:creationId xmlns:a16="http://schemas.microsoft.com/office/drawing/2014/main" id="{815D7550-E5C6-400C-BF35-1A3ADC013785}"/>
+                <a16:creationId xmlns:a16="http://schemas.microsoft.com/office/drawing/2014/main" id="{A8CA7D17-6DD1-4A6D-B96F-43EF534F7140}"/>
               </a:ext>
             </a:extLst>
           </p:cNvPr>
@@ -5669,7 +5669,7 @@
           <p:cNvPr id="5" name="">
             <a:extLst xmlns:a="http://schemas.openxmlformats.org/drawingml/2006/main">
               <a:ext uri="{FF2B5EF4-FFF2-40B4-BE49-F238E27FC236}">
-                <a16:creationId xmlns:a16="http://schemas.microsoft.com/office/drawing/2014/main" id="{E6CA6D70-C358-4BD8-95AE-2A459FC53D8E}"/>
+                <a16:creationId xmlns:a16="http://schemas.microsoft.com/office/drawing/2014/main" id="{68519382-A6A0-493E-82E9-6D2AA38FDB82}"/>
               </a:ext>
             </a:extLst>
           </p:cNvPr>
@@ -5726,7 +5726,7 @@
           <p:cNvPr id="6" name="">
             <a:extLst xmlns:a="http://schemas.openxmlformats.org/drawingml/2006/main">
               <a:ext uri="{FF2B5EF4-FFF2-40B4-BE49-F238E27FC236}">
-                <a16:creationId xmlns:a16="http://schemas.microsoft.com/office/drawing/2014/main" id="{6E3A6CFB-2110-4010-B6B7-CE85CB5A0DC0}"/>
+                <a16:creationId xmlns:a16="http://schemas.microsoft.com/office/drawing/2014/main" id="{355C10BA-AC2E-4B1F-BF0E-A35672CA18A0}"/>
               </a:ext>
             </a:extLst>
           </p:cNvPr>
@@ -5781,7 +5781,7 @@
     </p:spTree>
     <p:extLst>
       <p:ext uri="{BB962C8B-B14F-4D97-AF65-F5344CB8AC3E}">
-        <p14:creationId xmlns:p14="http://schemas.microsoft.com/office/powerpoint/2010/main" val="434137540"/>
+        <p14:creationId xmlns:p14="http://schemas.microsoft.com/office/powerpoint/2010/main" val="247751764"/>
       </p:ext>
     </p:extLst>
   </p:cSld>
@@ -5812,7 +5812,7 @@
           <p:cNvPr id="8" name="">
             <a:extLst xmlns:a="http://schemas.openxmlformats.org/drawingml/2006/main">
               <a:ext uri="{FF2B5EF4-FFF2-40B4-BE49-F238E27FC236}">
-                <a16:creationId xmlns:a16="http://schemas.microsoft.com/office/drawing/2014/main" id="{1E99B6D5-5AF5-4885-8B58-FFD626A7F581}"/>
+                <a16:creationId xmlns:a16="http://schemas.microsoft.com/office/drawing/2014/main" id="{61CBD759-A92A-43AB-B0CD-16FDD218E27B}"/>
               </a:ext>
             </a:extLst>
           </p:cNvPr>
@@ -5869,7 +5869,7 @@
           <p:cNvPr id="2" name="">
             <a:extLst xmlns:a="http://schemas.openxmlformats.org/drawingml/2006/main">
               <a:ext uri="{FF2B5EF4-FFF2-40B4-BE49-F238E27FC236}">
-                <a16:creationId xmlns:a16="http://schemas.microsoft.com/office/drawing/2014/main" id="{66CE2E2D-9E53-4A14-BF86-F958D289B37F}"/>
+                <a16:creationId xmlns:a16="http://schemas.microsoft.com/office/drawing/2014/main" id="{4AB290DC-86F4-405A-B893-A74F3748CF37}"/>
               </a:ext>
             </a:extLst>
           </p:cNvPr>
@@ -5926,7 +5926,7 @@
           <p:cNvPr id="3" name="">
             <a:extLst xmlns:a="http://schemas.openxmlformats.org/drawingml/2006/main">
               <a:ext uri="{FF2B5EF4-FFF2-40B4-BE49-F238E27FC236}">
-                <a16:creationId xmlns:a16="http://schemas.microsoft.com/office/drawing/2014/main" id="{66CC0C3A-EC52-4684-8142-9D7A18C380EF}"/>
+                <a16:creationId xmlns:a16="http://schemas.microsoft.com/office/drawing/2014/main" id="{0FBF66AA-C55A-4458-8C1E-7E2AE044D28D}"/>
               </a:ext>
             </a:extLst>
           </p:cNvPr>
@@ -5990,7 +5990,7 @@
         </p:xfrm>
         <a:graphic xmlns:a="http://schemas.openxmlformats.org/drawingml/2006/main">
           <a:graphicData uri="http://schemas.openxmlformats.org/drawingml/2006/chart">
-            <c:chart xmlns:r="http://schemas.openxmlformats.org/officeDocument/2006/relationships" xmlns:c="http://schemas.openxmlformats.org/drawingml/2006/chart" r:id="R811ecb31d2a74153"/>
+            <c:chart xmlns:r="http://schemas.openxmlformats.org/officeDocument/2006/relationships" xmlns:c="http://schemas.openxmlformats.org/drawingml/2006/chart" r:id="R6e94ccbb2b454d6b"/>
           </a:graphicData>
         </a:graphic>
       </p:graphicFrame>
@@ -5999,7 +5999,7 @@
           <p:cNvPr id="5" name="">
             <a:extLst xmlns:a="http://schemas.openxmlformats.org/drawingml/2006/main">
               <a:ext uri="{FF2B5EF4-FFF2-40B4-BE49-F238E27FC236}">
-                <a16:creationId xmlns:a16="http://schemas.microsoft.com/office/drawing/2014/main" id="{8B7203C1-05DE-4202-B382-BC4E2437E4CC}"/>
+                <a16:creationId xmlns:a16="http://schemas.microsoft.com/office/drawing/2014/main" id="{D9A87432-A30A-4D41-AE09-296723A1208A}"/>
               </a:ext>
             </a:extLst>
           </p:cNvPr>
@@ -6375,7 +6375,7 @@
           <p:cNvPr id="7" name="">
             <a:extLst xmlns:a="http://schemas.openxmlformats.org/drawingml/2006/main">
               <a:ext uri="{FF2B5EF4-FFF2-40B4-BE49-F238E27FC236}">
-                <a16:creationId xmlns:a16="http://schemas.microsoft.com/office/drawing/2014/main" id="{E3101F31-0DD2-4EE2-81E8-8538170AE011}"/>
+                <a16:creationId xmlns:a16="http://schemas.microsoft.com/office/drawing/2014/main" id="{20324562-8FFB-4977-8755-B3AD8D5E93D2}"/>
               </a:ext>
             </a:extLst>
           </p:cNvPr>
@@ -6430,7 +6430,7 @@
     </p:spTree>
     <p:extLst>
       <p:ext uri="{BB962C8B-B14F-4D97-AF65-F5344CB8AC3E}">
-        <p14:creationId xmlns:p14="http://schemas.microsoft.com/office/powerpoint/2010/main" val="983383537"/>
+        <p14:creationId xmlns:p14="http://schemas.microsoft.com/office/powerpoint/2010/main" val="1492781036"/>
       </p:ext>
     </p:extLst>
   </p:cSld>
@@ -6461,7 +6461,7 @@
           <p:cNvPr id="8" name="">
             <a:extLst xmlns:a="http://schemas.openxmlformats.org/drawingml/2006/main">
               <a:ext uri="{FF2B5EF4-FFF2-40B4-BE49-F238E27FC236}">
-                <a16:creationId xmlns:a16="http://schemas.microsoft.com/office/drawing/2014/main" id="{A72A60EC-3FB8-49BF-A977-6FF6539D4777}"/>
+                <a16:creationId xmlns:a16="http://schemas.microsoft.com/office/drawing/2014/main" id="{F2FBF76F-F6F2-45CF-9AF7-387A28601015}"/>
               </a:ext>
             </a:extLst>
           </p:cNvPr>
@@ -6518,7 +6518,7 @@
           <p:cNvPr id="2" name="">
             <a:extLst xmlns:a="http://schemas.openxmlformats.org/drawingml/2006/main">
               <a:ext uri="{FF2B5EF4-FFF2-40B4-BE49-F238E27FC236}">
-                <a16:creationId xmlns:a16="http://schemas.microsoft.com/office/drawing/2014/main" id="{A47AE7CF-7F68-4371-9CB3-B2795CEE718C}"/>
+                <a16:creationId xmlns:a16="http://schemas.microsoft.com/office/drawing/2014/main" id="{2E835FB7-952F-48D4-B55C-DF983F062E61}"/>
               </a:ext>
             </a:extLst>
           </p:cNvPr>
@@ -6575,7 +6575,7 @@
           <p:cNvPr id="3" name="">
             <a:extLst xmlns:a="http://schemas.openxmlformats.org/drawingml/2006/main">
               <a:ext uri="{FF2B5EF4-FFF2-40B4-BE49-F238E27FC236}">
-                <a16:creationId xmlns:a16="http://schemas.microsoft.com/office/drawing/2014/main" id="{BB35F858-C27E-48ED-9634-B8E74F81419D}"/>
+                <a16:creationId xmlns:a16="http://schemas.microsoft.com/office/drawing/2014/main" id="{A72AFF92-5BCE-401C-92BE-1AA3F7009F0D}"/>
               </a:ext>
             </a:extLst>
           </p:cNvPr>
@@ -6632,7 +6632,7 @@
           <p:cNvPr id="4" name="">
             <a:extLst xmlns:a="http://schemas.openxmlformats.org/drawingml/2006/main">
               <a:ext uri="{FF2B5EF4-FFF2-40B4-BE49-F238E27FC236}">
-                <a16:creationId xmlns:a16="http://schemas.microsoft.com/office/drawing/2014/main" id="{3EEBE425-F010-4A31-93B9-007CBDEC47CF}"/>
+                <a16:creationId xmlns:a16="http://schemas.microsoft.com/office/drawing/2014/main" id="{B9CC67C9-2A2D-4A52-8656-0544EB47A342}"/>
               </a:ext>
             </a:extLst>
           </p:cNvPr>
@@ -6861,7 +6861,7 @@
           <p:cNvPr id="6" name="">
             <a:extLst xmlns:a="http://schemas.openxmlformats.org/drawingml/2006/main">
               <a:ext uri="{FF2B5EF4-FFF2-40B4-BE49-F238E27FC236}">
-                <a16:creationId xmlns:a16="http://schemas.microsoft.com/office/drawing/2014/main" id="{6A1F1A8C-87D4-470D-BF77-8C088D7526AE}"/>
+                <a16:creationId xmlns:a16="http://schemas.microsoft.com/office/drawing/2014/main" id="{BF0BF223-FC26-4F89-BA22-58292310A1D6}"/>
               </a:ext>
             </a:extLst>
           </p:cNvPr>
@@ -6918,7 +6918,7 @@
           <p:cNvPr id="7" name="">
             <a:extLst xmlns:a="http://schemas.openxmlformats.org/drawingml/2006/main">
               <a:ext uri="{FF2B5EF4-FFF2-40B4-BE49-F238E27FC236}">
-                <a16:creationId xmlns:a16="http://schemas.microsoft.com/office/drawing/2014/main" id="{C7A73F23-89A3-4839-B830-F1828C7ABB6D}"/>
+                <a16:creationId xmlns:a16="http://schemas.microsoft.com/office/drawing/2014/main" id="{4229618F-5BC7-458A-BC36-DCA40B28C98A}"/>
               </a:ext>
             </a:extLst>
           </p:cNvPr>
@@ -6965,7 +6965,7 @@
                 <a:ea typeface="Bitstream Charter"/>
                 <a:cs typeface="Bitstream Charter"/>
               </a:rPr>
-              <a:t>Pendiente: apertura y refresco en Desktop.</a:t>
+              <a:t>PBIX entregado; apertura confirmada. Refresco por confirmar.</a:t>
             </a:r>
           </a:p>
           <a:p xmlns:a="http://schemas.openxmlformats.org/drawingml/2006/main">
@@ -6996,7 +6996,7 @@
     </p:spTree>
     <p:extLst>
       <p:ext uri="{BB962C8B-B14F-4D97-AF65-F5344CB8AC3E}">
-        <p14:creationId xmlns:p14="http://schemas.microsoft.com/office/powerpoint/2010/main" val="784182555"/>
+        <p14:creationId xmlns:p14="http://schemas.microsoft.com/office/powerpoint/2010/main" val="582844136"/>
       </p:ext>
     </p:extLst>
   </p:cSld>

</xml_diff>